<commit_message>
Revisionen Abb. 2.4, 3.1, 3.2, 3.5, 3.6, 3.10, 3.12, 3.13, 3.16, 3.20, 3.22, 3.23, 3.26, 3.31, Tab. 4.8 (DS); Rückfragen Abb. 3.193, 5.39
Co-Authored-By: Claude Sonnet 5.5 <noreply@anthropic.com>
Claude-Session: https://claude.ai/code/session_017NhurvpTPFv4izbogqC3xM
</commit_message>
<xml_diff>
--- a/abbildungen/kap2/Phasen_des_Planungs-_und_Steuerungsprozesses.pptx
+++ b/abbildungen/kap2/Phasen_des_Planungs-_und_Steuerungsprozesses.pptx
@@ -7,7 +7,7 @@
   <p:sldIdLst>
     <p:sldId id="256" r:id="rId7"/>
   </p:sldIdLst>
-  <p:sldSz cx="3960000" cy="3081600" type="screen4x3"/>
+  <p:sldSz cx="3960000" cy="2934000" type="screen4x3"/>
   <p:notesSz cx="6858000" cy="9144000"/>
   <p:defaultTextStyle>
     <a:defPPr>
@@ -3096,8 +3096,8 @@
         </p:nvSpPr>
         <p:spPr>
           <a:xfrm>
-            <a:off x="360000" y="180000"/>
-            <a:ext cx="1008000" cy="314706"/>
+            <a:off x="360000" y="14400"/>
+            <a:ext cx="1008000" cy="209804"/>
           </a:xfrm>
           <a:prstGeom prst="rect">
             <a:avLst/>
@@ -3125,15 +3125,14 @@
               </a:rPr>
               <a:t>Phasen des</a:t>
             </a:r>
-            <a:br>
-              <a:rPr lang="de-DE" sz="700" b="0" i="1">
-                <a:solidFill>
-                  <a:srgbClr val="1A1A1A"/>
-                </a:solidFill>
-                <a:latin typeface="Arial"/>
-                <a:cs typeface="Arial"/>
-              </a:rPr>
-            </a:br>
+          </a:p>
+          <a:p>
+            <a:pPr algn="ctr">
+              <a:lnSpc>
+                <a:spcPts val="826"/>
+              </a:lnSpc>
+              <a:buNone/>
+            </a:pPr>
             <a:r>
               <a:rPr lang="de-DE" sz="700" b="0" i="1">
                 <a:solidFill>
@@ -3154,8 +3153,8 @@
         </p:nvSpPr>
         <p:spPr>
           <a:xfrm>
-            <a:off x="1368000" y="180000"/>
-            <a:ext cx="1008000" cy="314706"/>
+            <a:off x="1332000" y="14400"/>
+            <a:ext cx="1080000" cy="209804"/>
           </a:xfrm>
           <a:prstGeom prst="rect">
             <a:avLst/>
@@ -3183,15 +3182,14 @@
               </a:rPr>
               <a:t>Tätigkeiten der</a:t>
             </a:r>
-            <a:br>
-              <a:rPr lang="de-DE" sz="700" b="0" i="1">
-                <a:solidFill>
-                  <a:srgbClr val="1A1A1A"/>
-                </a:solidFill>
-                <a:latin typeface="Arial"/>
-                <a:cs typeface="Arial"/>
-              </a:rPr>
-            </a:br>
+          </a:p>
+          <a:p>
+            <a:pPr algn="ctr">
+              <a:lnSpc>
+                <a:spcPts val="826"/>
+              </a:lnSpc>
+              <a:buNone/>
+            </a:pPr>
             <a:r>
               <a:rPr lang="de-DE" sz="700" b="0" i="1">
                 <a:solidFill>
@@ -3199,25 +3197,7 @@
                 </a:solidFill>
                 <a:latin typeface="Arial"/>
               </a:rPr>
-              <a:t>Unternehmungs-</a:t>
-            </a:r>
-            <a:br>
-              <a:rPr lang="de-DE" sz="700" b="0" i="1">
-                <a:solidFill>
-                  <a:srgbClr val="1A1A1A"/>
-                </a:solidFill>
-                <a:latin typeface="Arial"/>
-                <a:cs typeface="Arial"/>
-              </a:rPr>
-            </a:br>
-            <a:r>
-              <a:rPr lang="de-DE" sz="700" b="0" i="1">
-                <a:solidFill>
-                  <a:srgbClr val="1A1A1A"/>
-                </a:solidFill>
-                <a:latin typeface="Arial"/>
-              </a:rPr>
-              <a:t>führung</a:t>
+              <a:t>Unternehmungsführung</a:t>
             </a:r>
           </a:p>
         </p:txBody>
@@ -3230,7 +3210,7 @@
         </p:nvSpPr>
         <p:spPr>
           <a:xfrm>
-            <a:off x="360000" y="552306"/>
+            <a:off x="360000" y="404204"/>
             <a:ext cx="1008000" cy="289004"/>
           </a:xfrm>
           <a:prstGeom prst="rect">
@@ -3260,7 +3240,7 @@
         </p:nvSpPr>
         <p:spPr>
           <a:xfrm>
-            <a:off x="392400" y="591906"/>
+            <a:off x="392400" y="443804"/>
             <a:ext cx="115200" cy="209804"/>
           </a:xfrm>
           <a:prstGeom prst="rect">
@@ -3300,7 +3280,7 @@
         </p:nvSpPr>
         <p:spPr>
           <a:xfrm>
-            <a:off x="500400" y="591906"/>
+            <a:off x="500400" y="443804"/>
             <a:ext cx="835200" cy="209804"/>
           </a:xfrm>
           <a:prstGeom prst="rect">
@@ -3358,7 +3338,7 @@
         </p:nvSpPr>
         <p:spPr>
           <a:xfrm>
-            <a:off x="360000" y="841310"/>
+            <a:off x="360000" y="693208"/>
             <a:ext cx="1008000" cy="252000"/>
           </a:xfrm>
           <a:prstGeom prst="rect">
@@ -3388,7 +3368,7 @@
         </p:nvSpPr>
         <p:spPr>
           <a:xfrm>
-            <a:off x="392400" y="914859"/>
+            <a:off x="392400" y="766757"/>
             <a:ext cx="115200" cy="104902"/>
           </a:xfrm>
           <a:prstGeom prst="rect">
@@ -3428,7 +3408,7 @@
         </p:nvSpPr>
         <p:spPr>
           <a:xfrm>
-            <a:off x="500400" y="914859"/>
+            <a:off x="500400" y="766757"/>
             <a:ext cx="835200" cy="104902"/>
           </a:xfrm>
           <a:prstGeom prst="rect">
@@ -3468,7 +3448,7 @@
         </p:nvSpPr>
         <p:spPr>
           <a:xfrm>
-            <a:off x="360000" y="1093310"/>
+            <a:off x="360000" y="945208"/>
             <a:ext cx="1008000" cy="289004"/>
           </a:xfrm>
           <a:prstGeom prst="rect">
@@ -3498,7 +3478,7 @@
         </p:nvSpPr>
         <p:spPr>
           <a:xfrm>
-            <a:off x="392400" y="1132910"/>
+            <a:off x="392400" y="984808"/>
             <a:ext cx="115200" cy="209804"/>
           </a:xfrm>
           <a:prstGeom prst="rect">
@@ -3538,7 +3518,7 @@
         </p:nvSpPr>
         <p:spPr>
           <a:xfrm>
-            <a:off x="500400" y="1132910"/>
+            <a:off x="500400" y="984808"/>
             <a:ext cx="835200" cy="209804"/>
           </a:xfrm>
           <a:prstGeom prst="rect">
@@ -3596,7 +3576,7 @@
         </p:nvSpPr>
         <p:spPr>
           <a:xfrm>
-            <a:off x="360000" y="1382314"/>
+            <a:off x="360000" y="1234212"/>
             <a:ext cx="1008000" cy="289004"/>
           </a:xfrm>
           <a:prstGeom prst="rect">
@@ -3626,7 +3606,7 @@
         </p:nvSpPr>
         <p:spPr>
           <a:xfrm>
-            <a:off x="392400" y="1421914"/>
+            <a:off x="392400" y="1273812"/>
             <a:ext cx="115200" cy="209804"/>
           </a:xfrm>
           <a:prstGeom prst="rect">
@@ -3666,7 +3646,7 @@
         </p:nvSpPr>
         <p:spPr>
           <a:xfrm>
-            <a:off x="500400" y="1421914"/>
+            <a:off x="500400" y="1273812"/>
             <a:ext cx="835200" cy="209804"/>
           </a:xfrm>
           <a:prstGeom prst="rect">
@@ -3724,7 +3704,7 @@
         </p:nvSpPr>
         <p:spPr>
           <a:xfrm>
-            <a:off x="360000" y="1671318"/>
+            <a:off x="360000" y="1523216"/>
             <a:ext cx="1008000" cy="616410"/>
           </a:xfrm>
           <a:prstGeom prst="rect">
@@ -3754,7 +3734,7 @@
         </p:nvSpPr>
         <p:spPr>
           <a:xfrm>
-            <a:off x="392400" y="1927072"/>
+            <a:off x="392400" y="1778970"/>
             <a:ext cx="115200" cy="104902"/>
           </a:xfrm>
           <a:prstGeom prst="rect">
@@ -3794,7 +3774,7 @@
         </p:nvSpPr>
         <p:spPr>
           <a:xfrm>
-            <a:off x="500400" y="1927072"/>
+            <a:off x="500400" y="1778970"/>
             <a:ext cx="835200" cy="104902"/>
           </a:xfrm>
           <a:prstGeom prst="rect">
@@ -3834,7 +3814,7 @@
         </p:nvSpPr>
         <p:spPr>
           <a:xfrm>
-            <a:off x="360000" y="2287728"/>
+            <a:off x="360000" y="2139626"/>
             <a:ext cx="1008000" cy="498808"/>
           </a:xfrm>
           <a:prstGeom prst="rect">
@@ -3864,7 +3844,7 @@
         </p:nvSpPr>
         <p:spPr>
           <a:xfrm>
-            <a:off x="392400" y="2484681"/>
+            <a:off x="392400" y="2336579"/>
             <a:ext cx="115200" cy="104902"/>
           </a:xfrm>
           <a:prstGeom prst="rect">
@@ -3904,7 +3884,7 @@
         </p:nvSpPr>
         <p:spPr>
           <a:xfrm>
-            <a:off x="500400" y="2484681"/>
+            <a:off x="500400" y="2336579"/>
             <a:ext cx="835200" cy="104902"/>
           </a:xfrm>
           <a:prstGeom prst="rect">
@@ -3944,7 +3924,7 @@
         </p:nvSpPr>
         <p:spPr>
           <a:xfrm>
-            <a:off x="1368000" y="552306"/>
+            <a:off x="1368000" y="404204"/>
             <a:ext cx="1008000" cy="830008"/>
           </a:xfrm>
           <a:prstGeom prst="rect">
@@ -4010,7 +3990,7 @@
         </p:nvSpPr>
         <p:spPr>
           <a:xfrm>
-            <a:off x="1368000" y="1382314"/>
+            <a:off x="1368000" y="1234212"/>
             <a:ext cx="1008000" cy="289004"/>
           </a:xfrm>
           <a:prstGeom prst="rect">
@@ -4058,7 +4038,7 @@
         </p:nvSpPr>
         <p:spPr>
           <a:xfrm>
-            <a:off x="1368000" y="1671318"/>
+            <a:off x="1368000" y="1523216"/>
             <a:ext cx="1008000" cy="616410"/>
           </a:xfrm>
           <a:prstGeom prst="rect">
@@ -4182,7 +4162,7 @@
         </p:nvSpPr>
         <p:spPr>
           <a:xfrm>
-            <a:off x="1368000" y="2287728"/>
+            <a:off x="1368000" y="2139626"/>
             <a:ext cx="1008000" cy="498808"/>
           </a:xfrm>
           <a:prstGeom prst="rect">
@@ -4284,7 +4264,7 @@
         </p:nvSpPr>
         <p:spPr>
           <a:xfrm>
-            <a:off x="2448000" y="581106"/>
+            <a:off x="2448000" y="433004"/>
             <a:ext cx="50400" cy="772408"/>
           </a:xfrm>
           <a:custGeom>
@@ -4334,7 +4314,7 @@
         </p:nvSpPr>
         <p:spPr>
           <a:xfrm>
-            <a:off x="2498400" y="967310"/>
+            <a:off x="2498400" y="819208"/>
             <a:ext cx="50400" cy="0"/>
           </a:xfrm>
           <a:custGeom>
@@ -4378,7 +4358,7 @@
         </p:nvSpPr>
         <p:spPr>
           <a:xfrm>
-            <a:off x="2570400" y="750306"/>
+            <a:off x="2570400" y="602204"/>
             <a:ext cx="590400" cy="434008"/>
           </a:xfrm>
           <a:prstGeom prst="rect">
@@ -4471,7 +4451,7 @@
         </p:nvSpPr>
         <p:spPr>
           <a:xfrm>
-            <a:off x="2448000" y="1411114"/>
+            <a:off x="2448000" y="1263012"/>
             <a:ext cx="50400" cy="231404"/>
           </a:xfrm>
           <a:custGeom>
@@ -4521,7 +4501,7 @@
         </p:nvSpPr>
         <p:spPr>
           <a:xfrm>
-            <a:off x="2498400" y="1526816"/>
+            <a:off x="2498400" y="1378714"/>
             <a:ext cx="50400" cy="0"/>
           </a:xfrm>
           <a:custGeom>
@@ -4565,7 +4545,7 @@
         </p:nvSpPr>
         <p:spPr>
           <a:xfrm>
-            <a:off x="2570400" y="1414714"/>
+            <a:off x="2570400" y="1266612"/>
             <a:ext cx="590400" cy="224204"/>
           </a:xfrm>
           <a:prstGeom prst="rect">
@@ -4623,7 +4603,7 @@
         </p:nvSpPr>
         <p:spPr>
           <a:xfrm>
-            <a:off x="2448000" y="1700118"/>
+            <a:off x="2448000" y="1552016"/>
             <a:ext cx="50400" cy="558810"/>
           </a:xfrm>
           <a:custGeom>
@@ -4673,7 +4653,7 @@
         </p:nvSpPr>
         <p:spPr>
           <a:xfrm>
-            <a:off x="2498400" y="1979523"/>
+            <a:off x="2498400" y="1831421"/>
             <a:ext cx="50400" cy="0"/>
           </a:xfrm>
           <a:custGeom>
@@ -4717,7 +4697,7 @@
         </p:nvSpPr>
         <p:spPr>
           <a:xfrm>
-            <a:off x="2570400" y="1919872"/>
+            <a:off x="2570400" y="1771770"/>
             <a:ext cx="590400" cy="119302"/>
           </a:xfrm>
           <a:prstGeom prst="rect">
@@ -4757,7 +4737,7 @@
         </p:nvSpPr>
         <p:spPr>
           <a:xfrm>
-            <a:off x="2448000" y="2316528"/>
+            <a:off x="2448000" y="2168426"/>
             <a:ext cx="50400" cy="441208"/>
           </a:xfrm>
           <a:custGeom>
@@ -4807,7 +4787,7 @@
         </p:nvSpPr>
         <p:spPr>
           <a:xfrm>
-            <a:off x="2498400" y="2537132"/>
+            <a:off x="2498400" y="2389030"/>
             <a:ext cx="50400" cy="0"/>
           </a:xfrm>
           <a:custGeom>
@@ -4851,7 +4831,7 @@
         </p:nvSpPr>
         <p:spPr>
           <a:xfrm>
-            <a:off x="2570400" y="2477481"/>
+            <a:off x="2570400" y="2329379"/>
             <a:ext cx="590400" cy="119302"/>
           </a:xfrm>
           <a:prstGeom prst="rect">
@@ -4891,7 +4871,7 @@
         </p:nvSpPr>
         <p:spPr>
           <a:xfrm>
-            <a:off x="3204000" y="581106"/>
+            <a:off x="3204000" y="433004"/>
             <a:ext cx="50400" cy="1061412"/>
           </a:xfrm>
           <a:custGeom>
@@ -4941,7 +4921,7 @@
         </p:nvSpPr>
         <p:spPr>
           <a:xfrm>
-            <a:off x="3254400" y="1111812"/>
+            <a:off x="3254400" y="963710"/>
             <a:ext cx="50400" cy="0"/>
           </a:xfrm>
           <a:custGeom>
@@ -4985,7 +4965,7 @@
         </p:nvSpPr>
         <p:spPr>
           <a:xfrm>
-            <a:off x="3326400" y="999710"/>
+            <a:off x="3326400" y="851608"/>
             <a:ext cx="590400" cy="224204"/>
           </a:xfrm>
           <a:prstGeom prst="rect">
@@ -5042,7 +5022,7 @@
         </p:nvSpPr>
         <p:spPr>
           <a:xfrm>
-            <a:off x="3247200" y="1752221"/>
+            <a:off x="3247200" y="1748621"/>
             <a:ext cx="684000" cy="165600"/>
           </a:xfrm>
           <a:prstGeom prst="roundRect">
@@ -5092,8 +5072,8 @@
         </p:nvSpPr>
         <p:spPr>
           <a:xfrm>
-            <a:off x="2376000" y="1671318"/>
-            <a:ext cx="1213200" cy="80903"/>
+            <a:off x="2376000" y="1523216"/>
+            <a:ext cx="1213200" cy="225405"/>
           </a:xfrm>
           <a:custGeom>
             <a:avLst/>
@@ -5102,7 +5082,7 @@
             <a:cxnLst/>
             <a:rect l="l" t="t" r="r" b="b"/>
             <a:pathLst>
-              <a:path w="1213200" h="80903">
+              <a:path w="1213200" h="225405">
                 <a:moveTo>
                   <a:pt x="0" y="0"/>
                 </a:moveTo>
@@ -5110,7 +5090,7 @@
                   <a:pt x="1213200" y="0"/>
                 </a:lnTo>
                 <a:lnTo>
-                  <a:pt x="1213200" y="80903"/>
+                  <a:pt x="1213200" y="225405"/>
                 </a:lnTo>
               </a:path>
             </a:pathLst>
@@ -5141,7 +5121,7 @@
         </p:nvSpPr>
         <p:spPr>
           <a:xfrm>
-            <a:off x="2570400" y="1696518"/>
+            <a:off x="2570400" y="1548416"/>
             <a:ext cx="658800" cy="223200"/>
           </a:xfrm>
           <a:prstGeom prst="rect">
@@ -5199,8 +5179,8 @@
         </p:nvSpPr>
         <p:spPr>
           <a:xfrm>
-            <a:off x="108000" y="72000"/>
-            <a:ext cx="3481200" cy="2829736"/>
+            <a:off x="108000" y="310604"/>
+            <a:ext cx="3481200" cy="2443030"/>
           </a:xfrm>
           <a:custGeom>
             <a:avLst/>
@@ -5209,15 +5189,15 @@
             <a:cxnLst/>
             <a:rect l="l" t="t" r="r" b="b"/>
             <a:pathLst>
-              <a:path w="3481200" h="2829736">
+              <a:path w="3481200" h="2443030">
                 <a:moveTo>
-                  <a:pt x="3481200" y="1845821"/>
+                  <a:pt x="3481200" y="1603617"/>
                 </a:moveTo>
                 <a:lnTo>
-                  <a:pt x="3481200" y="2829736"/>
+                  <a:pt x="3481200" y="2443030"/>
                 </a:lnTo>
                 <a:lnTo>
-                  <a:pt x="0" y="2829736"/>
+                  <a:pt x="0" y="2443030"/>
                 </a:lnTo>
                 <a:lnTo>
                   <a:pt x="0" y="0"/>
@@ -5254,7 +5234,7 @@
         </p:nvSpPr>
         <p:spPr>
           <a:xfrm>
-            <a:off x="2808000" y="2923336"/>
+            <a:off x="2808000" y="2775234"/>
             <a:ext cx="1108800" cy="129600"/>
           </a:xfrm>
           <a:prstGeom prst="rect">
@@ -5294,7 +5274,7 @@
         </p:nvSpPr>
         <p:spPr>
           <a:xfrm>
-            <a:off x="244800" y="7200"/>
+            <a:off x="244800" y="245804"/>
             <a:ext cx="1080000" cy="129600"/>
           </a:xfrm>
           <a:prstGeom prst="rect">
@@ -5334,8 +5314,8 @@
         </p:nvSpPr>
         <p:spPr>
           <a:xfrm>
-            <a:off x="252000" y="140400"/>
-            <a:ext cx="0" cy="1839123"/>
+            <a:off x="252000" y="379004"/>
+            <a:ext cx="0" cy="1452417"/>
           </a:xfrm>
           <a:custGeom>
             <a:avLst/>
@@ -5344,12 +5324,12 @@
             <a:cxnLst/>
             <a:rect l="l" t="t" r="r" b="b"/>
             <a:pathLst>
-              <a:path w="0" h="1839123">
+              <a:path w="0" h="1452417">
                 <a:moveTo>
                   <a:pt x="0" y="0"/>
                 </a:moveTo>
                 <a:lnTo>
-                  <a:pt x="0" y="1839123"/>
+                  <a:pt x="0" y="1452417"/>
                 </a:lnTo>
               </a:path>
             </a:pathLst>
@@ -5379,7 +5359,7 @@
         </p:nvSpPr>
         <p:spPr>
           <a:xfrm>
-            <a:off x="252000" y="696808"/>
+            <a:off x="252000" y="548706"/>
             <a:ext cx="108000" cy="0"/>
           </a:xfrm>
           <a:custGeom>
@@ -5425,7 +5405,7 @@
         </p:nvSpPr>
         <p:spPr>
           <a:xfrm>
-            <a:off x="252000" y="967310"/>
+            <a:off x="252000" y="819208"/>
             <a:ext cx="108000" cy="0"/>
           </a:xfrm>
           <a:custGeom>
@@ -5471,7 +5451,7 @@
         </p:nvSpPr>
         <p:spPr>
           <a:xfrm>
-            <a:off x="252000" y="1237812"/>
+            <a:off x="252000" y="1089710"/>
             <a:ext cx="108000" cy="0"/>
           </a:xfrm>
           <a:custGeom>
@@ -5517,7 +5497,7 @@
         </p:nvSpPr>
         <p:spPr>
           <a:xfrm>
-            <a:off x="252000" y="1526816"/>
+            <a:off x="252000" y="1378714"/>
             <a:ext cx="108000" cy="0"/>
           </a:xfrm>
           <a:custGeom>
@@ -5563,7 +5543,7 @@
         </p:nvSpPr>
         <p:spPr>
           <a:xfrm>
-            <a:off x="252000" y="1979523"/>
+            <a:off x="252000" y="1831421"/>
             <a:ext cx="108000" cy="0"/>
           </a:xfrm>
           <a:custGeom>

</xml_diff>